<commit_message>
001_introduction DECK CLOSED: 49/49 certified (slide 25 attempt-1 PASS, slide 45 attempt-3 PASS after connector+badge fixes); close-out report + DB snapshot; skill memory: stroke-weight-truncation lesson + compaction self-amnesia incident; gitignore: lo_profile churn + gate locks + 58MB Mitchell PDF
</commit_message>
<xml_diff>
--- a/videos/deep-learning/001_introduction/recreated_pptx/slide_045_recreated.pptx
+++ b/videos/deep-learning/001_introduction/recreated_pptx/slide_045_recreated.pptx
@@ -1020,208 +1020,7 @@
       </p:sp>
       <p:sp>
         <p:nvSpPr>
-          <p:cNvPr id="5" name="Text 3"/>
-          <p:cNvSpPr/>
-          <p:nvPr/>
-        </p:nvSpPr>
-        <p:spPr>
-          <a:xfrm>
-            <a:off x="990600" y="1495920"/>
-            <a:ext cx="10236200" cy="1066800"/>
-          </a:xfrm>
-          <a:prstGeom prst="rect">
-            <a:avLst/>
-          </a:prstGeom>
-          <a:noFill/>
-          <a:ln/>
-        </p:spPr>
-        <p:txBody>
-          <a:bodyPr wrap="square" lIns="0" tIns="0" rIns="0" bIns="0" rtlCol="0" anchor="t"/>
-          <a:lstStyle/>
-          <a:p>
-            <a:pPr algn="l" indent="0" marL="0">
-              <a:lnSpc>
-                <a:spcPts val="2700"/>
-              </a:lnSpc>
-              <a:buNone/>
-            </a:pPr>
-            <a:r>
-              <a:rPr lang="en-US" sz="2100" dirty="0">
-                <a:solidFill>
-                  <a:srgbClr val="1A1A6E"/>
-                </a:solidFill>
-                <a:latin typeface="Times New Roman" pitchFamily="34" charset="0"/>
-                <a:ea typeface="Times New Roman" pitchFamily="34" charset="-122"/>
-                <a:cs typeface="Times New Roman" pitchFamily="34" charset="-120"/>
-              </a:rPr>
-              <a:t>Since Convolution is a DOT product (between filter values and corresponding image values),</a:t>
-            </a:r>
-            <a:endParaRPr lang="en-US" sz="2100" dirty="0"/>
-          </a:p>
-          <a:p>
-            <a:pPr algn="l" indent="0" marL="0">
-              <a:lnSpc>
-                <a:spcPts val="2700"/>
-              </a:lnSpc>
-              <a:buNone/>
-            </a:pPr>
-            <a:r>
-              <a:rPr lang="en-US" sz="2100" dirty="0">
-                <a:solidFill>
-                  <a:srgbClr val="1A1A6E"/>
-                </a:solidFill>
-                <a:latin typeface="Times New Roman" pitchFamily="34" charset="0"/>
-                <a:ea typeface="Times New Roman" pitchFamily="34" charset="-122"/>
-                <a:cs typeface="Times New Roman" pitchFamily="34" charset="-120"/>
-              </a:rPr>
-              <a:t>It can be applied as if it is a NN Layer</a:t>
-            </a:r>
-            <a:endParaRPr lang="en-US" sz="2100" dirty="0"/>
-          </a:p>
-          <a:p>
-            <a:pPr algn="l" indent="0" marL="0">
-              <a:lnSpc>
-                <a:spcPts val="2700"/>
-              </a:lnSpc>
-              <a:buNone/>
-            </a:pPr>
-            <a:r>
-              <a:rPr lang="en-US" sz="2100" b="1" dirty="0">
-                <a:solidFill>
-                  <a:srgbClr val="1A1A6E"/>
-                </a:solidFill>
-                <a:latin typeface="Times New Roman" pitchFamily="34" charset="0"/>
-                <a:ea typeface="Times New Roman" pitchFamily="34" charset="-122"/>
-                <a:cs typeface="Times New Roman" pitchFamily="34" charset="-120"/>
-              </a:rPr>
-              <a:t>Input</a:t>
-            </a:r>
-            <a:pPr algn="l" indent="0" marL="0">
-              <a:lnSpc>
-                <a:spcPts val="2700"/>
-              </a:lnSpc>
-              <a:buNone/>
-            </a:pPr>
-            <a:r>
-              <a:rPr lang="en-US" sz="2100" dirty="0">
-                <a:solidFill>
-                  <a:srgbClr val="1A1A6E"/>
-                </a:solidFill>
-                <a:latin typeface="Times New Roman" pitchFamily="34" charset="0"/>
-                <a:ea typeface="Times New Roman" pitchFamily="34" charset="-122"/>
-                <a:cs typeface="Times New Roman" pitchFamily="34" charset="-120"/>
-              </a:rPr>
-              <a:t>: image values, </a:t>
-            </a:r>
-            <a:pPr algn="l" indent="0" marL="0">
-              <a:lnSpc>
-                <a:spcPts val="2700"/>
-              </a:lnSpc>
-              <a:buNone/>
-            </a:pPr>
-            <a:r>
-              <a:rPr lang="en-US" sz="2100" b="1" dirty="0">
-                <a:solidFill>
-                  <a:srgbClr val="1A1A6E"/>
-                </a:solidFill>
-                <a:latin typeface="Times New Roman" pitchFamily="34" charset="0"/>
-                <a:ea typeface="Times New Roman" pitchFamily="34" charset="-122"/>
-                <a:cs typeface="Times New Roman" pitchFamily="34" charset="-120"/>
-              </a:rPr>
-              <a:t>Weights</a:t>
-            </a:r>
-            <a:pPr algn="l" indent="0" marL="0">
-              <a:lnSpc>
-                <a:spcPts val="2700"/>
-              </a:lnSpc>
-              <a:buNone/>
-            </a:pPr>
-            <a:r>
-              <a:rPr lang="en-US" sz="2100" dirty="0">
-                <a:solidFill>
-                  <a:srgbClr val="1A1A6E"/>
-                </a:solidFill>
-                <a:latin typeface="Times New Roman" pitchFamily="34" charset="0"/>
-                <a:ea typeface="Times New Roman" pitchFamily="34" charset="-122"/>
-                <a:cs typeface="Times New Roman" pitchFamily="34" charset="-120"/>
-              </a:rPr>
-              <a:t> : filter values, </a:t>
-            </a:r>
-            <a:pPr algn="l" indent="0" marL="0">
-              <a:lnSpc>
-                <a:spcPts val="2700"/>
-              </a:lnSpc>
-              <a:buNone/>
-            </a:pPr>
-            <a:r>
-              <a:rPr lang="en-US" sz="2100" b="1" dirty="0">
-                <a:solidFill>
-                  <a:srgbClr val="1A1A6E"/>
-                </a:solidFill>
-                <a:latin typeface="Times New Roman" pitchFamily="34" charset="0"/>
-                <a:ea typeface="Times New Roman" pitchFamily="34" charset="-122"/>
-                <a:cs typeface="Times New Roman" pitchFamily="34" charset="-120"/>
-              </a:rPr>
-              <a:t>Activation</a:t>
-            </a:r>
-            <a:pPr algn="l" indent="0" marL="0">
-              <a:lnSpc>
-                <a:spcPts val="2700"/>
-              </a:lnSpc>
-              <a:buNone/>
-            </a:pPr>
-            <a:r>
-              <a:rPr lang="en-US" sz="2100" dirty="0">
-                <a:solidFill>
-                  <a:srgbClr val="1A1A6E"/>
-                </a:solidFill>
-                <a:latin typeface="Times New Roman" pitchFamily="34" charset="0"/>
-                <a:ea typeface="Times New Roman" pitchFamily="34" charset="-122"/>
-                <a:cs typeface="Times New Roman" pitchFamily="34" charset="-120"/>
-              </a:rPr>
-              <a:t>: Linear, </a:t>
-            </a:r>
-            <a:pPr algn="l" indent="0" marL="0">
-              <a:lnSpc>
-                <a:spcPts val="2700"/>
-              </a:lnSpc>
-              <a:buNone/>
-            </a:pPr>
-            <a:r>
-              <a:rPr lang="en-US" sz="2100" b="1" dirty="0">
-                <a:solidFill>
-                  <a:srgbClr val="1A1A6E"/>
-                </a:solidFill>
-                <a:latin typeface="Times New Roman" pitchFamily="34" charset="0"/>
-                <a:ea typeface="Times New Roman" pitchFamily="34" charset="-122"/>
-                <a:cs typeface="Times New Roman" pitchFamily="34" charset="-120"/>
-              </a:rPr>
-              <a:t>Bias</a:t>
-            </a:r>
-            <a:pPr algn="l" indent="0" marL="0">
-              <a:lnSpc>
-                <a:spcPts val="2700"/>
-              </a:lnSpc>
-              <a:buNone/>
-            </a:pPr>
-            <a:r>
-              <a:rPr lang="en-US" sz="2100" dirty="0">
-                <a:solidFill>
-                  <a:srgbClr val="1A1A6E"/>
-                </a:solidFill>
-                <a:latin typeface="Times New Roman" pitchFamily="34" charset="0"/>
-                <a:ea typeface="Times New Roman" pitchFamily="34" charset="-122"/>
-                <a:cs typeface="Times New Roman" pitchFamily="34" charset="-120"/>
-              </a:rPr>
-              <a:t>:0</a:t>
-            </a:r>
-            <a:endParaRPr lang="en-US" sz="2100" dirty="0"/>
-          </a:p>
-        </p:txBody>
-      </p:sp>
-      <p:sp>
-        <p:nvSpPr>
-          <p:cNvPr id="6" name="Shape 4"/>
+          <p:cNvPr id="5" name="Shape 3"/>
           <p:cNvSpPr/>
           <p:nvPr/>
         </p:nvSpPr>
@@ -1246,7 +1045,7 @@
       </p:sp>
       <p:sp>
         <p:nvSpPr>
-          <p:cNvPr id="7" name="Text 5"/>
+          <p:cNvPr id="6" name="Text 4"/>
           <p:cNvSpPr/>
           <p:nvPr/>
         </p:nvSpPr>
@@ -1325,7 +1124,7 @@
       </p:sp>
       <p:sp>
         <p:nvSpPr>
-          <p:cNvPr id="8" name="Shape 6"/>
+          <p:cNvPr id="7" name="Shape 5"/>
           <p:cNvSpPr/>
           <p:nvPr/>
         </p:nvSpPr>
@@ -1350,7 +1149,7 @@
       </p:sp>
       <p:sp>
         <p:nvSpPr>
-          <p:cNvPr id="9" name="Text 7"/>
+          <p:cNvPr id="8" name="Text 6"/>
           <p:cNvSpPr/>
           <p:nvPr/>
         </p:nvSpPr>
@@ -1409,7 +1208,7 @@
       </p:sp>
       <p:sp>
         <p:nvSpPr>
-          <p:cNvPr id="10" name="Text 8"/>
+          <p:cNvPr id="9" name="Text 7"/>
           <p:cNvSpPr/>
           <p:nvPr/>
         </p:nvSpPr>
@@ -1451,7 +1250,7 @@
       </p:sp>
       <p:sp>
         <p:nvSpPr>
-          <p:cNvPr id="11" name="Text 9"/>
+          <p:cNvPr id="10" name="Text 8"/>
           <p:cNvSpPr/>
           <p:nvPr/>
         </p:nvSpPr>
@@ -1493,7 +1292,7 @@
       </p:sp>
       <p:sp>
         <p:nvSpPr>
-          <p:cNvPr id="12" name="Text 10"/>
+          <p:cNvPr id="11" name="Text 9"/>
           <p:cNvSpPr/>
           <p:nvPr/>
         </p:nvSpPr>
@@ -1535,7 +1334,7 @@
       </p:sp>
       <p:sp>
         <p:nvSpPr>
-          <p:cNvPr id="13" name="Text 11"/>
+          <p:cNvPr id="12" name="Text 10"/>
           <p:cNvSpPr/>
           <p:nvPr/>
         </p:nvSpPr>
@@ -1594,7 +1393,7 @@
       </p:sp>
       <p:sp>
         <p:nvSpPr>
-          <p:cNvPr id="14" name="Text 12"/>
+          <p:cNvPr id="13" name="Text 11"/>
           <p:cNvSpPr/>
           <p:nvPr/>
         </p:nvSpPr>
@@ -1636,7 +1435,7 @@
       </p:sp>
       <p:sp>
         <p:nvSpPr>
-          <p:cNvPr id="15" name="Text 13"/>
+          <p:cNvPr id="14" name="Text 12"/>
           <p:cNvSpPr/>
           <p:nvPr/>
         </p:nvSpPr>
@@ -1678,7 +1477,7 @@
       </p:sp>
       <p:sp>
         <p:nvSpPr>
-          <p:cNvPr id="16" name="Text 14"/>
+          <p:cNvPr id="15" name="Text 13"/>
           <p:cNvSpPr/>
           <p:nvPr/>
         </p:nvSpPr>
@@ -1720,7 +1519,7 @@
       </p:sp>
       <p:sp>
         <p:nvSpPr>
-          <p:cNvPr id="17" name="Shape 15"/>
+          <p:cNvPr id="16" name="Shape 14"/>
           <p:cNvSpPr/>
           <p:nvPr/>
         </p:nvSpPr>
@@ -1745,7 +1544,7 @@
       </p:sp>
       <p:sp>
         <p:nvSpPr>
-          <p:cNvPr id="18" name="Shape 16"/>
+          <p:cNvPr id="17" name="Shape 15"/>
           <p:cNvSpPr/>
           <p:nvPr/>
         </p:nvSpPr>
@@ -1770,7 +1569,7 @@
       </p:sp>
       <p:sp>
         <p:nvSpPr>
-          <p:cNvPr id="19" name="Shape 17"/>
+          <p:cNvPr id="18" name="Shape 16"/>
           <p:cNvSpPr/>
           <p:nvPr/>
         </p:nvSpPr>
@@ -1795,7 +1594,7 @@
       </p:sp>
       <p:sp>
         <p:nvSpPr>
-          <p:cNvPr id="20" name="Shape 18"/>
+          <p:cNvPr id="19" name="Shape 17"/>
           <p:cNvSpPr/>
           <p:nvPr/>
         </p:nvSpPr>
@@ -1820,7 +1619,7 @@
       </p:sp>
       <p:sp>
         <p:nvSpPr>
-          <p:cNvPr id="21" name="Text 19"/>
+          <p:cNvPr id="20" name="Text 18"/>
           <p:cNvSpPr/>
           <p:nvPr/>
         </p:nvSpPr>
@@ -1862,7 +1661,7 @@
       </p:sp>
       <p:sp>
         <p:nvSpPr>
-          <p:cNvPr id="22" name="Text 20"/>
+          <p:cNvPr id="21" name="Text 19"/>
           <p:cNvSpPr/>
           <p:nvPr/>
         </p:nvSpPr>
@@ -1904,7 +1703,7 @@
       </p:sp>
       <p:sp>
         <p:nvSpPr>
-          <p:cNvPr id="23" name="Text 21"/>
+          <p:cNvPr id="22" name="Text 20"/>
           <p:cNvSpPr/>
           <p:nvPr/>
         </p:nvSpPr>
@@ -1944,9 +1743,55 @@
           </a:p>
         </p:txBody>
       </p:sp>
+      <p:sp>
+        <p:nvSpPr>
+          <p:cNvPr id="23" name="Shape 21"/>
+          <p:cNvSpPr/>
+          <p:nvPr/>
+        </p:nvSpPr>
+        <p:spPr>
+          <a:xfrm>
+            <a:off x="6635750" y="5524500"/>
+            <a:ext cx="50800" cy="44450"/>
+          </a:xfrm>
+          <a:prstGeom prst="line">
+            <a:avLst/>
+          </a:prstGeom>
+          <a:noFill/>
+          <a:ln w="31750">
+            <a:solidFill>
+              <a:srgbClr val="454140"/>
+            </a:solidFill>
+            <a:prstDash val="solid"/>
+          </a:ln>
+        </p:spPr>
+      </p:sp>
+      <p:sp>
+        <p:nvSpPr>
+          <p:cNvPr id="24" name="Shape 22"/>
+          <p:cNvSpPr/>
+          <p:nvPr/>
+        </p:nvSpPr>
+        <p:spPr>
+          <a:xfrm>
+            <a:off x="6667500" y="5556250"/>
+            <a:ext cx="101600" cy="133350"/>
+          </a:xfrm>
+          <a:prstGeom prst="line">
+            <a:avLst/>
+          </a:prstGeom>
+          <a:noFill/>
+          <a:ln w="15875">
+            <a:solidFill>
+              <a:srgbClr val="454140"/>
+            </a:solidFill>
+            <a:prstDash val="solid"/>
+          </a:ln>
+        </p:spPr>
+      </p:sp>
       <p:pic>
         <p:nvPicPr>
-          <p:cNvPr id="24" name="Image 0" descr="/home/ahmed/Projects/ai_llm_slides/videos/deep-learning/001_introduction/recreated_pptx/build/assets/eq_045_a_rc.png">    </p:cNvPr>
+          <p:cNvPr id="25" name="Image 0" descr="/home/ahmed/Projects/ai_llm_slides/videos/deep-learning/001_introduction/recreated_pptx/build/assets/eq_045_a_rc.png">    </p:cNvPr>
           <p:cNvPicPr>
             <a:picLocks noChangeAspect="1"/>
           </p:cNvPicPr>
@@ -1970,7 +1815,7 @@
       </p:pic>
       <p:pic>
         <p:nvPicPr>
-          <p:cNvPr id="25" name="Image 1" descr="/home/ahmed/Projects/ai_llm_slides/videos/deep-learning/001_introduction/recreated_pptx/build/assets/eq_045_eq_a.png">    </p:cNvPr>
+          <p:cNvPr id="26" name="Image 1" descr="/home/ahmed/Projects/ai_llm_slides/videos/deep-learning/001_introduction/recreated_pptx/build/assets/eq_045_eq_a.png">    </p:cNvPr>
           <p:cNvPicPr>
             <a:picLocks noChangeAspect="1"/>
           </p:cNvPicPr>
@@ -1994,7 +1839,7 @@
       </p:pic>
       <p:pic>
         <p:nvPicPr>
-          <p:cNvPr id="26" name="Image 2" descr="/home/ahmed/Projects/ai_llm_slides/videos/deep-learning/001_introduction/recreated_pptx/build/assets/eq_045_sum1.png">    </p:cNvPr>
+          <p:cNvPr id="27" name="Image 2" descr="/home/ahmed/Projects/ai_llm_slides/videos/deep-learning/001_introduction/recreated_pptx/build/assets/eq_045_sum1.png">    </p:cNvPr>
           <p:cNvPicPr>
             <a:picLocks noChangeAspect="1"/>
           </p:cNvPicPr>
@@ -2018,7 +1863,7 @@
       </p:pic>
       <p:pic>
         <p:nvPicPr>
-          <p:cNvPr id="27" name="Image 3" descr="/home/ahmed/Projects/ai_llm_slides/videos/deep-learning/001_introduction/recreated_pptx/build/assets/eq_045_lim1u.png">    </p:cNvPr>
+          <p:cNvPr id="28" name="Image 3" descr="/home/ahmed/Projects/ai_llm_slides/videos/deep-learning/001_introduction/recreated_pptx/build/assets/eq_045_lim1u.png">    </p:cNvPr>
           <p:cNvPicPr>
             <a:picLocks noChangeAspect="1"/>
           </p:cNvPicPr>
@@ -2042,7 +1887,7 @@
       </p:pic>
       <p:pic>
         <p:nvPicPr>
-          <p:cNvPr id="28" name="Image 4" descr="/home/ahmed/Projects/ai_llm_slides/videos/deep-learning/001_introduction/recreated_pptx/build/assets/eq_045_lim1l.png">    </p:cNvPr>
+          <p:cNvPr id="29" name="Image 4" descr="/home/ahmed/Projects/ai_llm_slides/videos/deep-learning/001_introduction/recreated_pptx/build/assets/eq_045_lim1l.png">    </p:cNvPr>
           <p:cNvPicPr>
             <a:picLocks noChangeAspect="1"/>
           </p:cNvPicPr>
@@ -2066,7 +1911,7 @@
       </p:pic>
       <p:pic>
         <p:nvPicPr>
-          <p:cNvPr id="29" name="Image 5" descr="/home/ahmed/Projects/ai_llm_slides/videos/deep-learning/001_introduction/recreated_pptx/build/assets/eq_045_sum2.png">    </p:cNvPr>
+          <p:cNvPr id="30" name="Image 5" descr="/home/ahmed/Projects/ai_llm_slides/videos/deep-learning/001_introduction/recreated_pptx/build/assets/eq_045_sum2.png">    </p:cNvPr>
           <p:cNvPicPr>
             <a:picLocks noChangeAspect="1"/>
           </p:cNvPicPr>
@@ -2090,7 +1935,7 @@
       </p:pic>
       <p:pic>
         <p:nvPicPr>
-          <p:cNvPr id="30" name="Image 6" descr="/home/ahmed/Projects/ai_llm_slides/videos/deep-learning/001_introduction/recreated_pptx/build/assets/eq_045_lim2u.png">    </p:cNvPr>
+          <p:cNvPr id="31" name="Image 6" descr="/home/ahmed/Projects/ai_llm_slides/videos/deep-learning/001_introduction/recreated_pptx/build/assets/eq_045_lim2u.png">    </p:cNvPr>
           <p:cNvPicPr>
             <a:picLocks noChangeAspect="1"/>
           </p:cNvPicPr>
@@ -2114,7 +1959,7 @@
       </p:pic>
       <p:pic>
         <p:nvPicPr>
-          <p:cNvPr id="31" name="Image 7" descr="/home/ahmed/Projects/ai_llm_slides/videos/deep-learning/001_introduction/recreated_pptx/build/assets/eq_045_lim2l.png">    </p:cNvPr>
+          <p:cNvPr id="32" name="Image 7" descr="/home/ahmed/Projects/ai_llm_slides/videos/deep-learning/001_introduction/recreated_pptx/build/assets/eq_045_lim2l.png">    </p:cNvPr>
           <p:cNvPicPr>
             <a:picLocks noChangeAspect="1"/>
           </p:cNvPicPr>
@@ -2138,7 +1983,7 @@
       </p:pic>
       <p:pic>
         <p:nvPicPr>
-          <p:cNvPr id="32" name="Image 8" descr="/home/ahmed/Projects/ai_llm_slides/videos/deep-learning/001_introduction/recreated_pptx/build/assets/eq_045_x_a.png">    </p:cNvPr>
+          <p:cNvPr id="33" name="Image 8" descr="/home/ahmed/Projects/ai_llm_slides/videos/deep-learning/001_introduction/recreated_pptx/build/assets/eq_045_x_a.png">    </p:cNvPr>
           <p:cNvPicPr>
             <a:picLocks noChangeAspect="1"/>
           </p:cNvPicPr>
@@ -2162,7 +2007,7 @@
       </p:pic>
       <p:pic>
         <p:nvPicPr>
-          <p:cNvPr id="33" name="Image 9" descr="/home/ahmed/Projects/ai_llm_slides/videos/deep-learning/001_introduction/recreated_pptx/build/assets/eq_045_sub_a.png">    </p:cNvPr>
+          <p:cNvPr id="34" name="Image 9" descr="/home/ahmed/Projects/ai_llm_slides/videos/deep-learning/001_introduction/recreated_pptx/build/assets/eq_045_sub_a.png">    </p:cNvPr>
           <p:cNvPicPr>
             <a:picLocks noChangeAspect="1"/>
           </p:cNvPicPr>
@@ -2186,7 +2031,7 @@
       </p:pic>
       <p:pic>
         <p:nvPicPr>
-          <p:cNvPr id="34" name="Image 10" descr="/home/ahmed/Projects/ai_llm_slides/videos/deep-learning/001_introduction/recreated_pptx/build/assets/eq_045_dot_a.png">    </p:cNvPr>
+          <p:cNvPr id="35" name="Image 10" descr="/home/ahmed/Projects/ai_llm_slides/videos/deep-learning/001_introduction/recreated_pptx/build/assets/eq_045_dot_a.png">    </p:cNvPr>
           <p:cNvPicPr>
             <a:picLocks noChangeAspect="1"/>
           </p:cNvPicPr>
@@ -2210,7 +2055,7 @@
       </p:pic>
       <p:pic>
         <p:nvPicPr>
-          <p:cNvPr id="35" name="Image 11" descr="/home/ahmed/Projects/ai_llm_slides/videos/deep-learning/001_introduction/recreated_pptx/build/assets/eq_045_theta_a.png">    </p:cNvPr>
+          <p:cNvPr id="36" name="Image 11" descr="/home/ahmed/Projects/ai_llm_slides/videos/deep-learning/001_introduction/recreated_pptx/build/assets/eq_045_theta_a.png">    </p:cNvPr>
           <p:cNvPicPr>
             <a:picLocks noChangeAspect="1"/>
           </p:cNvPicPr>
@@ -2234,7 +2079,7 @@
       </p:pic>
       <p:pic>
         <p:nvPicPr>
-          <p:cNvPr id="36" name="Image 12" descr="/home/ahmed/Projects/ai_llm_slides/videos/deep-learning/001_introduction/recreated_pptx/build/assets/eq_045_ij_a.png">    </p:cNvPr>
+          <p:cNvPr id="37" name="Image 12" descr="/home/ahmed/Projects/ai_llm_slides/videos/deep-learning/001_introduction/recreated_pptx/build/assets/eq_045_ij_a.png">    </p:cNvPr>
           <p:cNvPicPr>
             <a:picLocks noChangeAspect="1"/>
           </p:cNvPicPr>
@@ -2258,7 +2103,7 @@
       </p:pic>
       <p:pic>
         <p:nvPicPr>
-          <p:cNvPr id="37" name="Image 13" descr="/home/ahmed/Projects/ai_llm_slides/videos/deep-learning/001_introduction/recreated_pptx/build/assets/eq_045_a_b.png">    </p:cNvPr>
+          <p:cNvPr id="38" name="Image 13" descr="/home/ahmed/Projects/ai_llm_slides/videos/deep-learning/001_introduction/recreated_pptx/build/assets/eq_045_a_b.png">    </p:cNvPr>
           <p:cNvPicPr>
             <a:picLocks noChangeAspect="1"/>
           </p:cNvPicPr>
@@ -2282,7 +2127,7 @@
       </p:pic>
       <p:pic>
         <p:nvPicPr>
-          <p:cNvPr id="38" name="Image 14" descr="/home/ahmed/Projects/ai_llm_slides/videos/deep-learning/001_introduction/recreated_pptx/build/assets/eq_045_rc_b.png">    </p:cNvPr>
+          <p:cNvPr id="39" name="Image 14" descr="/home/ahmed/Projects/ai_llm_slides/videos/deep-learning/001_introduction/recreated_pptx/build/assets/eq_045_rc_b.png">    </p:cNvPr>
           <p:cNvPicPr>
             <a:picLocks noChangeAspect="1"/>
           </p:cNvPicPr>
@@ -2306,7 +2151,7 @@
       </p:pic>
       <p:pic>
         <p:nvPicPr>
-          <p:cNvPr id="39" name="Image 15" descr="/home/ahmed/Projects/ai_llm_slides/videos/deep-learning/001_introduction/recreated_pptx/build/assets/eq_045_sim_b.png">    </p:cNvPr>
+          <p:cNvPr id="40" name="Image 15" descr="/home/ahmed/Projects/ai_llm_slides/videos/deep-learning/001_introduction/recreated_pptx/build/assets/eq_045_sim_b.png">    </p:cNvPr>
           <p:cNvPicPr>
             <a:picLocks noChangeAspect="1"/>
           </p:cNvPicPr>
@@ -2330,7 +2175,7 @@
       </p:pic>
       <p:pic>
         <p:nvPicPr>
-          <p:cNvPr id="40" name="Image 16" descr="/home/ahmed/Projects/ai_llm_slides/videos/deep-learning/001_introduction/recreated_pptx/build/assets/eq_045_x_b.png">    </p:cNvPr>
+          <p:cNvPr id="41" name="Image 16" descr="/home/ahmed/Projects/ai_llm_slides/videos/deep-learning/001_introduction/recreated_pptx/build/assets/eq_045_x_b.png">    </p:cNvPr>
           <p:cNvPicPr>
             <a:picLocks noChangeAspect="1"/>
           </p:cNvPicPr>
@@ -2354,7 +2199,7 @@
       </p:pic>
       <p:pic>
         <p:nvPicPr>
-          <p:cNvPr id="41" name="Image 17" descr="/home/ahmed/Projects/ai_llm_slides/videos/deep-learning/001_introduction/recreated_pptx/build/assets/eq_045_region_b.png">    </p:cNvPr>
+          <p:cNvPr id="42" name="Image 17" descr="/home/ahmed/Projects/ai_llm_slides/videos/deep-learning/001_introduction/recreated_pptx/build/assets/eq_045_region_b.png">    </p:cNvPr>
           <p:cNvPicPr>
             <a:picLocks noChangeAspect="1"/>
           </p:cNvPicPr>
@@ -2368,8 +2213,8 @@
         </p:blipFill>
         <p:spPr>
           <a:xfrm>
-            <a:off x="7099808" y="5124958"/>
-            <a:ext cx="707133" cy="138687"/>
+            <a:off x="7277608" y="5124958"/>
+            <a:ext cx="387093" cy="138687"/>
           </a:xfrm>
           <a:prstGeom prst="rect">
             <a:avLst/>
@@ -2378,7 +2223,7 @@
       </p:pic>
       <p:pic>
         <p:nvPicPr>
-          <p:cNvPr id="42" name="Image 18" descr="/home/ahmed/Projects/ai_llm_slides/videos/deep-learning/001_introduction/recreated_pptx/build/assets/eq_045_T_b.png">    </p:cNvPr>
+          <p:cNvPr id="43" name="Image 18" descr="/home/ahmed/Projects/ai_llm_slides/videos/deep-learning/001_introduction/recreated_pptx/build/assets/eq_045_T_b.png">    </p:cNvPr>
           <p:cNvPicPr>
             <a:picLocks noChangeAspect="1"/>
           </p:cNvPicPr>
@@ -2402,7 +2247,7 @@
       </p:pic>
       <p:pic>
         <p:nvPicPr>
-          <p:cNvPr id="43" name="Image 19" descr="/home/ahmed/Projects/ai_llm_slides/videos/deep-learning/001_introduction/recreated_pptx/build/assets/eq_045_dot_b.png">    </p:cNvPr>
+          <p:cNvPr id="44" name="Image 19" descr="/home/ahmed/Projects/ai_llm_slides/videos/deep-learning/001_introduction/recreated_pptx/build/assets/eq_045_dot_b.png">    </p:cNvPr>
           <p:cNvPicPr>
             <a:picLocks noChangeAspect="1"/>
           </p:cNvPicPr>
@@ -2426,7 +2271,7 @@
       </p:pic>
       <p:pic>
         <p:nvPicPr>
-          <p:cNvPr id="44" name="Image 20" descr="/home/ahmed/Projects/ai_llm_slides/videos/deep-learning/001_introduction/recreated_pptx/build/assets/eq_045_theta_b.png">    </p:cNvPr>
+          <p:cNvPr id="45" name="Image 20" descr="/home/ahmed/Projects/ai_llm_slides/videos/deep-learning/001_introduction/recreated_pptx/build/assets/eq_045_theta_b.png">    </p:cNvPr>
           <p:cNvPicPr>
             <a:picLocks noChangeAspect="1"/>
           </p:cNvPicPr>
@@ -2450,7 +2295,7 @@
       </p:pic>
       <p:pic>
         <p:nvPicPr>
-          <p:cNvPr id="45" name="Image 21" descr="/home/ahmed/Projects/ai_llm_slides/videos/deep-learning/001_introduction/recreated_pptx/build/assets/eq_045_frac_c.png">    </p:cNvPr>
+          <p:cNvPr id="46" name="Image 21" descr="/home/ahmed/Projects/ai_llm_slides/videos/deep-learning/001_introduction/recreated_pptx/build/assets/eq_045_frac_c.png">    </p:cNvPr>
           <p:cNvPicPr>
             <a:picLocks noChangeAspect="1"/>
           </p:cNvPicPr>
@@ -2474,7 +2319,7 @@
       </p:pic>
       <p:pic>
         <p:nvPicPr>
-          <p:cNvPr id="46" name="Image 22" descr="/home/ahmed/Projects/ai_llm_slides/videos/deep-learning/001_introduction/recreated_pptx/build/assets/eq_045_eq_c.png">    </p:cNvPr>
+          <p:cNvPr id="47" name="Image 22" descr="/home/ahmed/Projects/ai_llm_slides/videos/deep-learning/001_introduction/recreated_pptx/build/assets/eq_045_eq_c.png">    </p:cNvPr>
           <p:cNvPicPr>
             <a:picLocks noChangeAspect="1"/>
           </p:cNvPicPr>
@@ -2498,7 +2343,7 @@
       </p:pic>
       <p:pic>
         <p:nvPicPr>
-          <p:cNvPr id="47" name="Image 23" descr="/home/ahmed/Projects/ai_llm_slides/videos/deep-learning/001_introduction/recreated_pptx/build/assets/eq_045_sum3.png">    </p:cNvPr>
+          <p:cNvPr id="48" name="Image 23" descr="/home/ahmed/Projects/ai_llm_slides/videos/deep-learning/001_introduction/recreated_pptx/build/assets/eq_045_sum3.png">    </p:cNvPr>
           <p:cNvPicPr>
             <a:picLocks noChangeAspect="1"/>
           </p:cNvPicPr>
@@ -2522,7 +2367,7 @@
       </p:pic>
       <p:pic>
         <p:nvPicPr>
-          <p:cNvPr id="48" name="Image 24" descr="/home/ahmed/Projects/ai_llm_slides/videos/deep-learning/001_introduction/recreated_pptx/build/assets/eq_045_lim3u.png">    </p:cNvPr>
+          <p:cNvPr id="49" name="Image 24" descr="/home/ahmed/Projects/ai_llm_slides/videos/deep-learning/001_introduction/recreated_pptx/build/assets/eq_045_lim3u.png">    </p:cNvPr>
           <p:cNvPicPr>
             <a:picLocks noChangeAspect="1"/>
           </p:cNvPicPr>
@@ -2546,7 +2391,7 @@
       </p:pic>
       <p:pic>
         <p:nvPicPr>
-          <p:cNvPr id="49" name="Image 25" descr="/home/ahmed/Projects/ai_llm_slides/videos/deep-learning/001_introduction/recreated_pptx/build/assets/eq_045_lim3l.png">    </p:cNvPr>
+          <p:cNvPr id="50" name="Image 25" descr="/home/ahmed/Projects/ai_llm_slides/videos/deep-learning/001_introduction/recreated_pptx/build/assets/eq_045_lim3l.png">    </p:cNvPr>
           <p:cNvPicPr>
             <a:picLocks noChangeAspect="1"/>
           </p:cNvPicPr>
@@ -2570,7 +2415,7 @@
       </p:pic>
       <p:pic>
         <p:nvPicPr>
-          <p:cNvPr id="50" name="Image 26" descr="/home/ahmed/Projects/ai_llm_slides/videos/deep-learning/001_introduction/recreated_pptx/build/assets/eq_045_sum4.png">    </p:cNvPr>
+          <p:cNvPr id="51" name="Image 26" descr="/home/ahmed/Projects/ai_llm_slides/videos/deep-learning/001_introduction/recreated_pptx/build/assets/eq_045_sum4.png">    </p:cNvPr>
           <p:cNvPicPr>
             <a:picLocks noChangeAspect="1"/>
           </p:cNvPicPr>
@@ -2594,7 +2439,7 @@
       </p:pic>
       <p:pic>
         <p:nvPicPr>
-          <p:cNvPr id="51" name="Image 27" descr="/home/ahmed/Projects/ai_llm_slides/videos/deep-learning/001_introduction/recreated_pptx/build/assets/eq_045_lim4u.png">    </p:cNvPr>
+          <p:cNvPr id="52" name="Image 27" descr="/home/ahmed/Projects/ai_llm_slides/videos/deep-learning/001_introduction/recreated_pptx/build/assets/eq_045_lim4u.png">    </p:cNvPr>
           <p:cNvPicPr>
             <a:picLocks noChangeAspect="1"/>
           </p:cNvPicPr>
@@ -2618,7 +2463,7 @@
       </p:pic>
       <p:pic>
         <p:nvPicPr>
-          <p:cNvPr id="52" name="Image 28" descr="/home/ahmed/Projects/ai_llm_slides/videos/deep-learning/001_introduction/recreated_pptx/build/assets/eq_045_lim4l.png">    </p:cNvPr>
+          <p:cNvPr id="53" name="Image 28" descr="/home/ahmed/Projects/ai_llm_slides/videos/deep-learning/001_introduction/recreated_pptx/build/assets/eq_045_lim4l.png">    </p:cNvPr>
           <p:cNvPicPr>
             <a:picLocks noChangeAspect="1"/>
           </p:cNvPicPr>
@@ -2642,7 +2487,7 @@
       </p:pic>
       <p:pic>
         <p:nvPicPr>
-          <p:cNvPr id="53" name="Image 29" descr="/home/ahmed/Projects/ai_llm_slides/videos/deep-learning/001_introduction/recreated_pptx/build/assets/eq_045_x_c.png">    </p:cNvPr>
+          <p:cNvPr id="54" name="Image 29" descr="/home/ahmed/Projects/ai_llm_slides/videos/deep-learning/001_introduction/recreated_pptx/build/assets/eq_045_x_c.png">    </p:cNvPr>
           <p:cNvPicPr>
             <a:picLocks noChangeAspect="1"/>
           </p:cNvPicPr>
@@ -2666,7 +2511,7 @@
       </p:pic>
       <p:pic>
         <p:nvPicPr>
-          <p:cNvPr id="54" name="Image 30" descr="/home/ahmed/Projects/ai_llm_slides/videos/deep-learning/001_introduction/recreated_pptx/build/assets/eq_045_sub_c.png">    </p:cNvPr>
+          <p:cNvPr id="55" name="Image 30" descr="/home/ahmed/Projects/ai_llm_slides/videos/deep-learning/001_introduction/recreated_pptx/build/assets/eq_045_sub_c.png">    </p:cNvPr>
           <p:cNvPicPr>
             <a:picLocks noChangeAspect="1"/>
           </p:cNvPicPr>
@@ -2690,7 +2535,7 @@
       </p:pic>
       <p:sp>
         <p:nvSpPr>
-          <p:cNvPr id="55" name="Shape 22"/>
+          <p:cNvPr id="56" name="Shape 23"/>
           <p:cNvSpPr/>
           <p:nvPr/>
         </p:nvSpPr>
@@ -2715,7 +2560,7 @@
       </p:sp>
       <p:sp>
         <p:nvSpPr>
-          <p:cNvPr id="56" name="Text 23"/>
+          <p:cNvPr id="57" name="Text 24"/>
           <p:cNvSpPr/>
           <p:nvPr/>
         </p:nvSpPr>
@@ -2774,7 +2619,7 @@
       </p:sp>
       <p:sp>
         <p:nvSpPr>
-          <p:cNvPr id="57" name="Shape 24"/>
+          <p:cNvPr id="58" name="Shape 25"/>
           <p:cNvSpPr/>
           <p:nvPr/>
         </p:nvSpPr>
@@ -2799,7 +2644,7 @@
       </p:sp>
       <p:sp>
         <p:nvSpPr>
-          <p:cNvPr id="58" name="Text 25"/>
+          <p:cNvPr id="59" name="Text 26"/>
           <p:cNvSpPr/>
           <p:nvPr/>
         </p:nvSpPr>
@@ -2858,7 +2703,7 @@
       </p:sp>
       <p:sp>
         <p:nvSpPr>
-          <p:cNvPr id="59" name="Shape 26"/>
+          <p:cNvPr id="60" name="Shape 27"/>
           <p:cNvSpPr/>
           <p:nvPr/>
         </p:nvSpPr>
@@ -2882,20 +2727,20 @@
       </p:sp>
       <p:sp>
         <p:nvSpPr>
-          <p:cNvPr id="60" name="Shape 27"/>
-          <p:cNvSpPr/>
-          <p:nvPr/>
-        </p:nvSpPr>
-        <p:spPr>
-          <a:xfrm flipH="1">
-            <a:off x="8674100" y="4406900"/>
-            <a:ext cx="101600" cy="177800"/>
+          <p:cNvPr id="61" name="Shape 28"/>
+          <p:cNvSpPr/>
+          <p:nvPr/>
+        </p:nvSpPr>
+        <p:spPr>
+          <a:xfrm>
+            <a:off x="8813800" y="4406900"/>
+            <a:ext cx="139700" cy="88900"/>
           </a:xfrm>
           <a:prstGeom prst="line">
             <a:avLst/>
           </a:prstGeom>
           <a:noFill/>
-          <a:ln w="12700">
+          <a:ln w="38100">
             <a:solidFill>
               <a:srgbClr val="C00000"/>
             </a:solidFill>
@@ -2905,7 +2750,53 @@
       </p:sp>
       <p:sp>
         <p:nvSpPr>
-          <p:cNvPr id="61" name="Shape 28"/>
+          <p:cNvPr id="62" name="Shape 29"/>
+          <p:cNvSpPr/>
+          <p:nvPr/>
+        </p:nvSpPr>
+        <p:spPr>
+          <a:xfrm>
+            <a:off x="8991600" y="4533900"/>
+            <a:ext cx="349250" cy="247650"/>
+          </a:xfrm>
+          <a:prstGeom prst="line">
+            <a:avLst/>
+          </a:prstGeom>
+          <a:noFill/>
+          <a:ln w="12700">
+            <a:solidFill>
+              <a:srgbClr val="BFBBB8"/>
+            </a:solidFill>
+            <a:prstDash val="solid"/>
+          </a:ln>
+        </p:spPr>
+      </p:sp>
+      <p:sp>
+        <p:nvSpPr>
+          <p:cNvPr id="63" name="Shape 30"/>
+          <p:cNvSpPr/>
+          <p:nvPr/>
+        </p:nvSpPr>
+        <p:spPr>
+          <a:xfrm>
+            <a:off x="8915400" y="5194300"/>
+            <a:ext cx="425450" cy="279400"/>
+          </a:xfrm>
+          <a:prstGeom prst="line">
+            <a:avLst/>
+          </a:prstGeom>
+          <a:noFill/>
+          <a:ln w="12700">
+            <a:solidFill>
+              <a:srgbClr val="BFBBB8"/>
+            </a:solidFill>
+            <a:prstDash val="solid"/>
+          </a:ln>
+        </p:spPr>
+      </p:sp>
+      <p:sp>
+        <p:nvSpPr>
+          <p:cNvPr id="64" name="Shape 31"/>
           <p:cNvSpPr/>
           <p:nvPr/>
         </p:nvSpPr>
@@ -2913,6 +2804,46 @@
           <a:xfrm>
             <a:off x="9931400" y="609600"/>
             <a:ext cx="1422400" cy="1320800"/>
+          </a:xfrm>
+          <a:prstGeom prst="star16">
+            <a:avLst/>
+          </a:prstGeom>
+          <a:solidFill>
+            <a:srgbClr val="C00000"/>
+          </a:solidFill>
+          <a:ln/>
+        </p:spPr>
+      </p:sp>
+      <p:sp>
+        <p:nvSpPr>
+          <p:cNvPr id="65" name="Shape 32"/>
+          <p:cNvSpPr/>
+          <p:nvPr/>
+        </p:nvSpPr>
+        <p:spPr>
+          <a:xfrm>
+            <a:off x="9950450" y="628650"/>
+            <a:ext cx="1384300" cy="1282700"/>
+          </a:xfrm>
+          <a:prstGeom prst="star16">
+            <a:avLst/>
+          </a:prstGeom>
+          <a:solidFill>
+            <a:srgbClr val="FFFFFF"/>
+          </a:solidFill>
+          <a:ln/>
+        </p:spPr>
+      </p:sp>
+      <p:sp>
+        <p:nvSpPr>
+          <p:cNvPr id="66" name="Shape 33"/>
+          <p:cNvSpPr/>
+          <p:nvPr/>
+        </p:nvSpPr>
+        <p:spPr>
+          <a:xfrm>
+            <a:off x="9969500" y="647700"/>
+            <a:ext cx="1346200" cy="1244600"/>
           </a:xfrm>
           <a:prstGeom prst="star16">
             <a:avLst/>
@@ -2920,17 +2851,636 @@
           <a:solidFill>
             <a:srgbClr val="F0F6CE"/>
           </a:solidFill>
-          <a:ln w="19050">
-            <a:solidFill>
-              <a:srgbClr val="C00000"/>
-            </a:solidFill>
-            <a:prstDash val="solid"/>
-          </a:ln>
-        </p:spPr>
-      </p:sp>
-      <p:sp>
-        <p:nvSpPr>
-          <p:cNvPr id="62" name="Text 29"/>
+          <a:ln/>
+        </p:spPr>
+      </p:sp>
+      <p:sp>
+        <p:nvSpPr>
+          <p:cNvPr id="67" name="Text 34"/>
+          <p:cNvSpPr/>
+          <p:nvPr/>
+        </p:nvSpPr>
+        <p:spPr>
+          <a:xfrm rot="20880000">
+            <a:off x="9890125" y="1117600"/>
+            <a:ext cx="1524000" cy="304800"/>
+          </a:xfrm>
+          <a:prstGeom prst="rect">
+            <a:avLst/>
+          </a:prstGeom>
+          <a:noFill/>
+          <a:ln/>
+        </p:spPr>
+        <p:txBody>
+          <a:bodyPr wrap="square" lIns="0" tIns="0" rIns="0" bIns="0" rtlCol="0" anchor="ctr"/>
+          <a:lstStyle/>
+          <a:p>
+            <a:pPr algn="ctr" indent="0" marL="0">
+              <a:buNone/>
+            </a:pPr>
+            <a:r>
+              <a:rPr lang="en-US" sz="1700" b="1" i="1" dirty="0">
+                <a:solidFill>
+                  <a:srgbClr val="FFFFFF"/>
+                </a:solidFill>
+                <a:latin typeface="Times New Roman" pitchFamily="34" charset="0"/>
+                <a:ea typeface="Times New Roman" pitchFamily="34" charset="-122"/>
+                <a:cs typeface="Times New Roman" pitchFamily="34" charset="-120"/>
+              </a:rPr>
+              <a:t>Important</a:t>
+            </a:r>
+            <a:endParaRPr lang="en-US" sz="1700" dirty="0"/>
+          </a:p>
+        </p:txBody>
+      </p:sp>
+      <p:sp>
+        <p:nvSpPr>
+          <p:cNvPr id="68" name="Text 35"/>
+          <p:cNvSpPr/>
+          <p:nvPr/>
+        </p:nvSpPr>
+        <p:spPr>
+          <a:xfrm rot="20880000">
+            <a:off x="9899650" y="1117600"/>
+            <a:ext cx="1524000" cy="304800"/>
+          </a:xfrm>
+          <a:prstGeom prst="rect">
+            <a:avLst/>
+          </a:prstGeom>
+          <a:noFill/>
+          <a:ln/>
+        </p:spPr>
+        <p:txBody>
+          <a:bodyPr wrap="square" lIns="0" tIns="0" rIns="0" bIns="0" rtlCol="0" anchor="ctr"/>
+          <a:lstStyle/>
+          <a:p>
+            <a:pPr algn="ctr" indent="0" marL="0">
+              <a:buNone/>
+            </a:pPr>
+            <a:r>
+              <a:rPr lang="en-US" sz="1700" b="1" i="1" dirty="0">
+                <a:solidFill>
+                  <a:srgbClr val="FFFFFF"/>
+                </a:solidFill>
+                <a:latin typeface="Times New Roman" pitchFamily="34" charset="0"/>
+                <a:ea typeface="Times New Roman" pitchFamily="34" charset="-122"/>
+                <a:cs typeface="Times New Roman" pitchFamily="34" charset="-120"/>
+              </a:rPr>
+              <a:t>Important</a:t>
+            </a:r>
+            <a:endParaRPr lang="en-US" sz="1700" dirty="0"/>
+          </a:p>
+        </p:txBody>
+      </p:sp>
+      <p:sp>
+        <p:nvSpPr>
+          <p:cNvPr id="69" name="Text 36"/>
+          <p:cNvSpPr/>
+          <p:nvPr/>
+        </p:nvSpPr>
+        <p:spPr>
+          <a:xfrm rot="20880000">
+            <a:off x="9887335" y="1124335"/>
+            <a:ext cx="1524000" cy="304800"/>
+          </a:xfrm>
+          <a:prstGeom prst="rect">
+            <a:avLst/>
+          </a:prstGeom>
+          <a:noFill/>
+          <a:ln/>
+        </p:spPr>
+        <p:txBody>
+          <a:bodyPr wrap="square" lIns="0" tIns="0" rIns="0" bIns="0" rtlCol="0" anchor="ctr"/>
+          <a:lstStyle/>
+          <a:p>
+            <a:pPr algn="ctr" indent="0" marL="0">
+              <a:buNone/>
+            </a:pPr>
+            <a:r>
+              <a:rPr lang="en-US" sz="1700" b="1" i="1" dirty="0">
+                <a:solidFill>
+                  <a:srgbClr val="FFFFFF"/>
+                </a:solidFill>
+                <a:latin typeface="Times New Roman" pitchFamily="34" charset="0"/>
+                <a:ea typeface="Times New Roman" pitchFamily="34" charset="-122"/>
+                <a:cs typeface="Times New Roman" pitchFamily="34" charset="-120"/>
+              </a:rPr>
+              <a:t>Important</a:t>
+            </a:r>
+            <a:endParaRPr lang="en-US" sz="1700" dirty="0"/>
+          </a:p>
+        </p:txBody>
+      </p:sp>
+      <p:sp>
+        <p:nvSpPr>
+          <p:cNvPr id="70" name="Text 37"/>
+          <p:cNvSpPr/>
+          <p:nvPr/>
+        </p:nvSpPr>
+        <p:spPr>
+          <a:xfrm rot="20880000">
+            <a:off x="9894070" y="1131070"/>
+            <a:ext cx="1524000" cy="304800"/>
+          </a:xfrm>
+          <a:prstGeom prst="rect">
+            <a:avLst/>
+          </a:prstGeom>
+          <a:noFill/>
+          <a:ln/>
+        </p:spPr>
+        <p:txBody>
+          <a:bodyPr wrap="square" lIns="0" tIns="0" rIns="0" bIns="0" rtlCol="0" anchor="ctr"/>
+          <a:lstStyle/>
+          <a:p>
+            <a:pPr algn="ctr" indent="0" marL="0">
+              <a:buNone/>
+            </a:pPr>
+            <a:r>
+              <a:rPr lang="en-US" sz="1700" b="1" i="1" dirty="0">
+                <a:solidFill>
+                  <a:srgbClr val="FFFFFF"/>
+                </a:solidFill>
+                <a:latin typeface="Times New Roman" pitchFamily="34" charset="0"/>
+                <a:ea typeface="Times New Roman" pitchFamily="34" charset="-122"/>
+                <a:cs typeface="Times New Roman" pitchFamily="34" charset="-120"/>
+              </a:rPr>
+              <a:t>Important</a:t>
+            </a:r>
+            <a:endParaRPr lang="en-US" sz="1700" dirty="0"/>
+          </a:p>
+        </p:txBody>
+      </p:sp>
+      <p:sp>
+        <p:nvSpPr>
+          <p:cNvPr id="71" name="Text 38"/>
+          <p:cNvSpPr/>
+          <p:nvPr/>
+        </p:nvSpPr>
+        <p:spPr>
+          <a:xfrm rot="20880000">
+            <a:off x="9880600" y="1127125"/>
+            <a:ext cx="1524000" cy="304800"/>
+          </a:xfrm>
+          <a:prstGeom prst="rect">
+            <a:avLst/>
+          </a:prstGeom>
+          <a:noFill/>
+          <a:ln/>
+        </p:spPr>
+        <p:txBody>
+          <a:bodyPr wrap="square" lIns="0" tIns="0" rIns="0" bIns="0" rtlCol="0" anchor="ctr"/>
+          <a:lstStyle/>
+          <a:p>
+            <a:pPr algn="ctr" indent="0" marL="0">
+              <a:buNone/>
+            </a:pPr>
+            <a:r>
+              <a:rPr lang="en-US" sz="1700" b="1" i="1" dirty="0">
+                <a:solidFill>
+                  <a:srgbClr val="FFFFFF"/>
+                </a:solidFill>
+                <a:latin typeface="Times New Roman" pitchFamily="34" charset="0"/>
+                <a:ea typeface="Times New Roman" pitchFamily="34" charset="-122"/>
+                <a:cs typeface="Times New Roman" pitchFamily="34" charset="-120"/>
+              </a:rPr>
+              <a:t>Important</a:t>
+            </a:r>
+            <a:endParaRPr lang="en-US" sz="1700" dirty="0"/>
+          </a:p>
+        </p:txBody>
+      </p:sp>
+      <p:sp>
+        <p:nvSpPr>
+          <p:cNvPr id="72" name="Text 39"/>
+          <p:cNvSpPr/>
+          <p:nvPr/>
+        </p:nvSpPr>
+        <p:spPr>
+          <a:xfrm rot="20880000">
+            <a:off x="9880600" y="1136650"/>
+            <a:ext cx="1524000" cy="304800"/>
+          </a:xfrm>
+          <a:prstGeom prst="rect">
+            <a:avLst/>
+          </a:prstGeom>
+          <a:noFill/>
+          <a:ln/>
+        </p:spPr>
+        <p:txBody>
+          <a:bodyPr wrap="square" lIns="0" tIns="0" rIns="0" bIns="0" rtlCol="0" anchor="ctr"/>
+          <a:lstStyle/>
+          <a:p>
+            <a:pPr algn="ctr" indent="0" marL="0">
+              <a:buNone/>
+            </a:pPr>
+            <a:r>
+              <a:rPr lang="en-US" sz="1700" b="1" i="1" dirty="0">
+                <a:solidFill>
+                  <a:srgbClr val="FFFFFF"/>
+                </a:solidFill>
+                <a:latin typeface="Times New Roman" pitchFamily="34" charset="0"/>
+                <a:ea typeface="Times New Roman" pitchFamily="34" charset="-122"/>
+                <a:cs typeface="Times New Roman" pitchFamily="34" charset="-120"/>
+              </a:rPr>
+              <a:t>Important</a:t>
+            </a:r>
+            <a:endParaRPr lang="en-US" sz="1700" dirty="0"/>
+          </a:p>
+        </p:txBody>
+      </p:sp>
+      <p:sp>
+        <p:nvSpPr>
+          <p:cNvPr id="73" name="Text 40"/>
+          <p:cNvSpPr/>
+          <p:nvPr/>
+        </p:nvSpPr>
+        <p:spPr>
+          <a:xfrm rot="20880000">
+            <a:off x="9873865" y="1124335"/>
+            <a:ext cx="1524000" cy="304800"/>
+          </a:xfrm>
+          <a:prstGeom prst="rect">
+            <a:avLst/>
+          </a:prstGeom>
+          <a:noFill/>
+          <a:ln/>
+        </p:spPr>
+        <p:txBody>
+          <a:bodyPr wrap="square" lIns="0" tIns="0" rIns="0" bIns="0" rtlCol="0" anchor="ctr"/>
+          <a:lstStyle/>
+          <a:p>
+            <a:pPr algn="ctr" indent="0" marL="0">
+              <a:buNone/>
+            </a:pPr>
+            <a:r>
+              <a:rPr lang="en-US" sz="1700" b="1" i="1" dirty="0">
+                <a:solidFill>
+                  <a:srgbClr val="FFFFFF"/>
+                </a:solidFill>
+                <a:latin typeface="Times New Roman" pitchFamily="34" charset="0"/>
+                <a:ea typeface="Times New Roman" pitchFamily="34" charset="-122"/>
+                <a:cs typeface="Times New Roman" pitchFamily="34" charset="-120"/>
+              </a:rPr>
+              <a:t>Important</a:t>
+            </a:r>
+            <a:endParaRPr lang="en-US" sz="1700" dirty="0"/>
+          </a:p>
+        </p:txBody>
+      </p:sp>
+      <p:sp>
+        <p:nvSpPr>
+          <p:cNvPr id="74" name="Text 41"/>
+          <p:cNvSpPr/>
+          <p:nvPr/>
+        </p:nvSpPr>
+        <p:spPr>
+          <a:xfrm rot="20880000">
+            <a:off x="9867130" y="1131070"/>
+            <a:ext cx="1524000" cy="304800"/>
+          </a:xfrm>
+          <a:prstGeom prst="rect">
+            <a:avLst/>
+          </a:prstGeom>
+          <a:noFill/>
+          <a:ln/>
+        </p:spPr>
+        <p:txBody>
+          <a:bodyPr wrap="square" lIns="0" tIns="0" rIns="0" bIns="0" rtlCol="0" anchor="ctr"/>
+          <a:lstStyle/>
+          <a:p>
+            <a:pPr algn="ctr" indent="0" marL="0">
+              <a:buNone/>
+            </a:pPr>
+            <a:r>
+              <a:rPr lang="en-US" sz="1700" b="1" i="1" dirty="0">
+                <a:solidFill>
+                  <a:srgbClr val="FFFFFF"/>
+                </a:solidFill>
+                <a:latin typeface="Times New Roman" pitchFamily="34" charset="0"/>
+                <a:ea typeface="Times New Roman" pitchFamily="34" charset="-122"/>
+                <a:cs typeface="Times New Roman" pitchFamily="34" charset="-120"/>
+              </a:rPr>
+              <a:t>Important</a:t>
+            </a:r>
+            <a:endParaRPr lang="en-US" sz="1700" dirty="0"/>
+          </a:p>
+        </p:txBody>
+      </p:sp>
+      <p:sp>
+        <p:nvSpPr>
+          <p:cNvPr id="75" name="Text 42"/>
+          <p:cNvSpPr/>
+          <p:nvPr/>
+        </p:nvSpPr>
+        <p:spPr>
+          <a:xfrm rot="20880000">
+            <a:off x="9871075" y="1117600"/>
+            <a:ext cx="1524000" cy="304800"/>
+          </a:xfrm>
+          <a:prstGeom prst="rect">
+            <a:avLst/>
+          </a:prstGeom>
+          <a:noFill/>
+          <a:ln/>
+        </p:spPr>
+        <p:txBody>
+          <a:bodyPr wrap="square" lIns="0" tIns="0" rIns="0" bIns="0" rtlCol="0" anchor="ctr"/>
+          <a:lstStyle/>
+          <a:p>
+            <a:pPr algn="ctr" indent="0" marL="0">
+              <a:buNone/>
+            </a:pPr>
+            <a:r>
+              <a:rPr lang="en-US" sz="1700" b="1" i="1" dirty="0">
+                <a:solidFill>
+                  <a:srgbClr val="FFFFFF"/>
+                </a:solidFill>
+                <a:latin typeface="Times New Roman" pitchFamily="34" charset="0"/>
+                <a:ea typeface="Times New Roman" pitchFamily="34" charset="-122"/>
+                <a:cs typeface="Times New Roman" pitchFamily="34" charset="-120"/>
+              </a:rPr>
+              <a:t>Important</a:t>
+            </a:r>
+            <a:endParaRPr lang="en-US" sz="1700" dirty="0"/>
+          </a:p>
+        </p:txBody>
+      </p:sp>
+      <p:sp>
+        <p:nvSpPr>
+          <p:cNvPr id="76" name="Text 43"/>
+          <p:cNvSpPr/>
+          <p:nvPr/>
+        </p:nvSpPr>
+        <p:spPr>
+          <a:xfrm rot="20880000">
+            <a:off x="9861550" y="1117600"/>
+            <a:ext cx="1524000" cy="304800"/>
+          </a:xfrm>
+          <a:prstGeom prst="rect">
+            <a:avLst/>
+          </a:prstGeom>
+          <a:noFill/>
+          <a:ln/>
+        </p:spPr>
+        <p:txBody>
+          <a:bodyPr wrap="square" lIns="0" tIns="0" rIns="0" bIns="0" rtlCol="0" anchor="ctr"/>
+          <a:lstStyle/>
+          <a:p>
+            <a:pPr algn="ctr" indent="0" marL="0">
+              <a:buNone/>
+            </a:pPr>
+            <a:r>
+              <a:rPr lang="en-US" sz="1700" b="1" i="1" dirty="0">
+                <a:solidFill>
+                  <a:srgbClr val="FFFFFF"/>
+                </a:solidFill>
+                <a:latin typeface="Times New Roman" pitchFamily="34" charset="0"/>
+                <a:ea typeface="Times New Roman" pitchFamily="34" charset="-122"/>
+                <a:cs typeface="Times New Roman" pitchFamily="34" charset="-120"/>
+              </a:rPr>
+              <a:t>Important</a:t>
+            </a:r>
+            <a:endParaRPr lang="en-US" sz="1700" dirty="0"/>
+          </a:p>
+        </p:txBody>
+      </p:sp>
+      <p:sp>
+        <p:nvSpPr>
+          <p:cNvPr id="77" name="Text 44"/>
+          <p:cNvSpPr/>
+          <p:nvPr/>
+        </p:nvSpPr>
+        <p:spPr>
+          <a:xfrm rot="20880000">
+            <a:off x="9873865" y="1110865"/>
+            <a:ext cx="1524000" cy="304800"/>
+          </a:xfrm>
+          <a:prstGeom prst="rect">
+            <a:avLst/>
+          </a:prstGeom>
+          <a:noFill/>
+          <a:ln/>
+        </p:spPr>
+        <p:txBody>
+          <a:bodyPr wrap="square" lIns="0" tIns="0" rIns="0" bIns="0" rtlCol="0" anchor="ctr"/>
+          <a:lstStyle/>
+          <a:p>
+            <a:pPr algn="ctr" indent="0" marL="0">
+              <a:buNone/>
+            </a:pPr>
+            <a:r>
+              <a:rPr lang="en-US" sz="1700" b="1" i="1" dirty="0">
+                <a:solidFill>
+                  <a:srgbClr val="FFFFFF"/>
+                </a:solidFill>
+                <a:latin typeface="Times New Roman" pitchFamily="34" charset="0"/>
+                <a:ea typeface="Times New Roman" pitchFamily="34" charset="-122"/>
+                <a:cs typeface="Times New Roman" pitchFamily="34" charset="-120"/>
+              </a:rPr>
+              <a:t>Important</a:t>
+            </a:r>
+            <a:endParaRPr lang="en-US" sz="1700" dirty="0"/>
+          </a:p>
+        </p:txBody>
+      </p:sp>
+      <p:sp>
+        <p:nvSpPr>
+          <p:cNvPr id="78" name="Text 45"/>
+          <p:cNvSpPr/>
+          <p:nvPr/>
+        </p:nvSpPr>
+        <p:spPr>
+          <a:xfrm rot="20880000">
+            <a:off x="9867130" y="1104130"/>
+            <a:ext cx="1524000" cy="304800"/>
+          </a:xfrm>
+          <a:prstGeom prst="rect">
+            <a:avLst/>
+          </a:prstGeom>
+          <a:noFill/>
+          <a:ln/>
+        </p:spPr>
+        <p:txBody>
+          <a:bodyPr wrap="square" lIns="0" tIns="0" rIns="0" bIns="0" rtlCol="0" anchor="ctr"/>
+          <a:lstStyle/>
+          <a:p>
+            <a:pPr algn="ctr" indent="0" marL="0">
+              <a:buNone/>
+            </a:pPr>
+            <a:r>
+              <a:rPr lang="en-US" sz="1700" b="1" i="1" dirty="0">
+                <a:solidFill>
+                  <a:srgbClr val="FFFFFF"/>
+                </a:solidFill>
+                <a:latin typeface="Times New Roman" pitchFamily="34" charset="0"/>
+                <a:ea typeface="Times New Roman" pitchFamily="34" charset="-122"/>
+                <a:cs typeface="Times New Roman" pitchFamily="34" charset="-120"/>
+              </a:rPr>
+              <a:t>Important</a:t>
+            </a:r>
+            <a:endParaRPr lang="en-US" sz="1700" dirty="0"/>
+          </a:p>
+        </p:txBody>
+      </p:sp>
+      <p:sp>
+        <p:nvSpPr>
+          <p:cNvPr id="79" name="Text 46"/>
+          <p:cNvSpPr/>
+          <p:nvPr/>
+        </p:nvSpPr>
+        <p:spPr>
+          <a:xfrm rot="20880000">
+            <a:off x="9880600" y="1108075"/>
+            <a:ext cx="1524000" cy="304800"/>
+          </a:xfrm>
+          <a:prstGeom prst="rect">
+            <a:avLst/>
+          </a:prstGeom>
+          <a:noFill/>
+          <a:ln/>
+        </p:spPr>
+        <p:txBody>
+          <a:bodyPr wrap="square" lIns="0" tIns="0" rIns="0" bIns="0" rtlCol="0" anchor="ctr"/>
+          <a:lstStyle/>
+          <a:p>
+            <a:pPr algn="ctr" indent="0" marL="0">
+              <a:buNone/>
+            </a:pPr>
+            <a:r>
+              <a:rPr lang="en-US" sz="1700" b="1" i="1" dirty="0">
+                <a:solidFill>
+                  <a:srgbClr val="FFFFFF"/>
+                </a:solidFill>
+                <a:latin typeface="Times New Roman" pitchFamily="34" charset="0"/>
+                <a:ea typeface="Times New Roman" pitchFamily="34" charset="-122"/>
+                <a:cs typeface="Times New Roman" pitchFamily="34" charset="-120"/>
+              </a:rPr>
+              <a:t>Important</a:t>
+            </a:r>
+            <a:endParaRPr lang="en-US" sz="1700" dirty="0"/>
+          </a:p>
+        </p:txBody>
+      </p:sp>
+      <p:sp>
+        <p:nvSpPr>
+          <p:cNvPr id="80" name="Text 47"/>
+          <p:cNvSpPr/>
+          <p:nvPr/>
+        </p:nvSpPr>
+        <p:spPr>
+          <a:xfrm rot="20880000">
+            <a:off x="9880600" y="1098550"/>
+            <a:ext cx="1524000" cy="304800"/>
+          </a:xfrm>
+          <a:prstGeom prst="rect">
+            <a:avLst/>
+          </a:prstGeom>
+          <a:noFill/>
+          <a:ln/>
+        </p:spPr>
+        <p:txBody>
+          <a:bodyPr wrap="square" lIns="0" tIns="0" rIns="0" bIns="0" rtlCol="0" anchor="ctr"/>
+          <a:lstStyle/>
+          <a:p>
+            <a:pPr algn="ctr" indent="0" marL="0">
+              <a:buNone/>
+            </a:pPr>
+            <a:r>
+              <a:rPr lang="en-US" sz="1700" b="1" i="1" dirty="0">
+                <a:solidFill>
+                  <a:srgbClr val="FFFFFF"/>
+                </a:solidFill>
+                <a:latin typeface="Times New Roman" pitchFamily="34" charset="0"/>
+                <a:ea typeface="Times New Roman" pitchFamily="34" charset="-122"/>
+                <a:cs typeface="Times New Roman" pitchFamily="34" charset="-120"/>
+              </a:rPr>
+              <a:t>Important</a:t>
+            </a:r>
+            <a:endParaRPr lang="en-US" sz="1700" dirty="0"/>
+          </a:p>
+        </p:txBody>
+      </p:sp>
+      <p:sp>
+        <p:nvSpPr>
+          <p:cNvPr id="81" name="Text 48"/>
+          <p:cNvSpPr/>
+          <p:nvPr/>
+        </p:nvSpPr>
+        <p:spPr>
+          <a:xfrm rot="20880000">
+            <a:off x="9887335" y="1110865"/>
+            <a:ext cx="1524000" cy="304800"/>
+          </a:xfrm>
+          <a:prstGeom prst="rect">
+            <a:avLst/>
+          </a:prstGeom>
+          <a:noFill/>
+          <a:ln/>
+        </p:spPr>
+        <p:txBody>
+          <a:bodyPr wrap="square" lIns="0" tIns="0" rIns="0" bIns="0" rtlCol="0" anchor="ctr"/>
+          <a:lstStyle/>
+          <a:p>
+            <a:pPr algn="ctr" indent="0" marL="0">
+              <a:buNone/>
+            </a:pPr>
+            <a:r>
+              <a:rPr lang="en-US" sz="1700" b="1" i="1" dirty="0">
+                <a:solidFill>
+                  <a:srgbClr val="FFFFFF"/>
+                </a:solidFill>
+                <a:latin typeface="Times New Roman" pitchFamily="34" charset="0"/>
+                <a:ea typeface="Times New Roman" pitchFamily="34" charset="-122"/>
+                <a:cs typeface="Times New Roman" pitchFamily="34" charset="-120"/>
+              </a:rPr>
+              <a:t>Important</a:t>
+            </a:r>
+            <a:endParaRPr lang="en-US" sz="1700" dirty="0"/>
+          </a:p>
+        </p:txBody>
+      </p:sp>
+      <p:sp>
+        <p:nvSpPr>
+          <p:cNvPr id="82" name="Text 49"/>
+          <p:cNvSpPr/>
+          <p:nvPr/>
+        </p:nvSpPr>
+        <p:spPr>
+          <a:xfrm rot="20880000">
+            <a:off x="9894070" y="1104130"/>
+            <a:ext cx="1524000" cy="304800"/>
+          </a:xfrm>
+          <a:prstGeom prst="rect">
+            <a:avLst/>
+          </a:prstGeom>
+          <a:noFill/>
+          <a:ln/>
+        </p:spPr>
+        <p:txBody>
+          <a:bodyPr wrap="square" lIns="0" tIns="0" rIns="0" bIns="0" rtlCol="0" anchor="ctr"/>
+          <a:lstStyle/>
+          <a:p>
+            <a:pPr algn="ctr" indent="0" marL="0">
+              <a:buNone/>
+            </a:pPr>
+            <a:r>
+              <a:rPr lang="en-US" sz="1700" b="1" i="1" dirty="0">
+                <a:solidFill>
+                  <a:srgbClr val="FFFFFF"/>
+                </a:solidFill>
+                <a:latin typeface="Times New Roman" pitchFamily="34" charset="0"/>
+                <a:ea typeface="Times New Roman" pitchFamily="34" charset="-122"/>
+                <a:cs typeface="Times New Roman" pitchFamily="34" charset="-120"/>
+              </a:rPr>
+              <a:t>Important</a:t>
+            </a:r>
+            <a:endParaRPr lang="en-US" sz="1700" dirty="0"/>
+          </a:p>
+        </p:txBody>
+      </p:sp>
+      <p:sp>
+        <p:nvSpPr>
+          <p:cNvPr id="83" name="Text 50"/>
           <p:cNvSpPr/>
           <p:nvPr/>
         </p:nvSpPr>
@@ -2969,7 +3519,208 @@
       </p:sp>
       <p:sp>
         <p:nvSpPr>
-          <p:cNvPr id="63" name="Shape 30"/>
+          <p:cNvPr id="84" name="Text 51"/>
+          <p:cNvSpPr/>
+          <p:nvPr/>
+        </p:nvSpPr>
+        <p:spPr>
+          <a:xfrm>
+            <a:off x="990600" y="1495920"/>
+            <a:ext cx="10236200" cy="1066800"/>
+          </a:xfrm>
+          <a:prstGeom prst="rect">
+            <a:avLst/>
+          </a:prstGeom>
+          <a:noFill/>
+          <a:ln/>
+        </p:spPr>
+        <p:txBody>
+          <a:bodyPr wrap="square" lIns="0" tIns="0" rIns="0" bIns="0" rtlCol="0" anchor="t"/>
+          <a:lstStyle/>
+          <a:p>
+            <a:pPr algn="l" indent="0" marL="0">
+              <a:lnSpc>
+                <a:spcPts val="2700"/>
+              </a:lnSpc>
+              <a:buNone/>
+            </a:pPr>
+            <a:r>
+              <a:rPr lang="en-US" sz="2100" dirty="0">
+                <a:solidFill>
+                  <a:srgbClr val="1A1A6E"/>
+                </a:solidFill>
+                <a:latin typeface="Times New Roman" pitchFamily="34" charset="0"/>
+                <a:ea typeface="Times New Roman" pitchFamily="34" charset="-122"/>
+                <a:cs typeface="Times New Roman" pitchFamily="34" charset="-120"/>
+              </a:rPr>
+              <a:t>Since Convolution is a DOT product (between filter values and corresponding image values),</a:t>
+            </a:r>
+            <a:endParaRPr lang="en-US" sz="2100" dirty="0"/>
+          </a:p>
+          <a:p>
+            <a:pPr algn="l" indent="0" marL="0">
+              <a:lnSpc>
+                <a:spcPts val="2700"/>
+              </a:lnSpc>
+              <a:buNone/>
+            </a:pPr>
+            <a:r>
+              <a:rPr lang="en-US" sz="2100" dirty="0">
+                <a:solidFill>
+                  <a:srgbClr val="1A1A6E"/>
+                </a:solidFill>
+                <a:latin typeface="Times New Roman" pitchFamily="34" charset="0"/>
+                <a:ea typeface="Times New Roman" pitchFamily="34" charset="-122"/>
+                <a:cs typeface="Times New Roman" pitchFamily="34" charset="-120"/>
+              </a:rPr>
+              <a:t>It can be applied as if it is a NN Layer</a:t>
+            </a:r>
+            <a:endParaRPr lang="en-US" sz="2100" dirty="0"/>
+          </a:p>
+          <a:p>
+            <a:pPr algn="l" indent="0" marL="0">
+              <a:lnSpc>
+                <a:spcPts val="2700"/>
+              </a:lnSpc>
+              <a:buNone/>
+            </a:pPr>
+            <a:r>
+              <a:rPr lang="en-US" sz="2100" b="1" dirty="0">
+                <a:solidFill>
+                  <a:srgbClr val="1A1A6E"/>
+                </a:solidFill>
+                <a:latin typeface="Times New Roman" pitchFamily="34" charset="0"/>
+                <a:ea typeface="Times New Roman" pitchFamily="34" charset="-122"/>
+                <a:cs typeface="Times New Roman" pitchFamily="34" charset="-120"/>
+              </a:rPr>
+              <a:t>Input</a:t>
+            </a:r>
+            <a:pPr algn="l" indent="0" marL="0">
+              <a:lnSpc>
+                <a:spcPts val="2700"/>
+              </a:lnSpc>
+              <a:buNone/>
+            </a:pPr>
+            <a:r>
+              <a:rPr lang="en-US" sz="2100" dirty="0">
+                <a:solidFill>
+                  <a:srgbClr val="1A1A6E"/>
+                </a:solidFill>
+                <a:latin typeface="Times New Roman" pitchFamily="34" charset="0"/>
+                <a:ea typeface="Times New Roman" pitchFamily="34" charset="-122"/>
+                <a:cs typeface="Times New Roman" pitchFamily="34" charset="-120"/>
+              </a:rPr>
+              <a:t>: image values, </a:t>
+            </a:r>
+            <a:pPr algn="l" indent="0" marL="0">
+              <a:lnSpc>
+                <a:spcPts val="2700"/>
+              </a:lnSpc>
+              <a:buNone/>
+            </a:pPr>
+            <a:r>
+              <a:rPr lang="en-US" sz="2100" b="1" dirty="0">
+                <a:solidFill>
+                  <a:srgbClr val="1A1A6E"/>
+                </a:solidFill>
+                <a:latin typeface="Times New Roman" pitchFamily="34" charset="0"/>
+                <a:ea typeface="Times New Roman" pitchFamily="34" charset="-122"/>
+                <a:cs typeface="Times New Roman" pitchFamily="34" charset="-120"/>
+              </a:rPr>
+              <a:t>Weights</a:t>
+            </a:r>
+            <a:pPr algn="l" indent="0" marL="0">
+              <a:lnSpc>
+                <a:spcPts val="2700"/>
+              </a:lnSpc>
+              <a:buNone/>
+            </a:pPr>
+            <a:r>
+              <a:rPr lang="en-US" sz="2100" dirty="0">
+                <a:solidFill>
+                  <a:srgbClr val="1A1A6E"/>
+                </a:solidFill>
+                <a:latin typeface="Times New Roman" pitchFamily="34" charset="0"/>
+                <a:ea typeface="Times New Roman" pitchFamily="34" charset="-122"/>
+                <a:cs typeface="Times New Roman" pitchFamily="34" charset="-120"/>
+              </a:rPr>
+              <a:t> : filter values, </a:t>
+            </a:r>
+            <a:pPr algn="l" indent="0" marL="0">
+              <a:lnSpc>
+                <a:spcPts val="2700"/>
+              </a:lnSpc>
+              <a:buNone/>
+            </a:pPr>
+            <a:r>
+              <a:rPr lang="en-US" sz="2100" b="1" dirty="0">
+                <a:solidFill>
+                  <a:srgbClr val="1A1A6E"/>
+                </a:solidFill>
+                <a:latin typeface="Times New Roman" pitchFamily="34" charset="0"/>
+                <a:ea typeface="Times New Roman" pitchFamily="34" charset="-122"/>
+                <a:cs typeface="Times New Roman" pitchFamily="34" charset="-120"/>
+              </a:rPr>
+              <a:t>Activation</a:t>
+            </a:r>
+            <a:pPr algn="l" indent="0" marL="0">
+              <a:lnSpc>
+                <a:spcPts val="2700"/>
+              </a:lnSpc>
+              <a:buNone/>
+            </a:pPr>
+            <a:r>
+              <a:rPr lang="en-US" sz="2100" dirty="0">
+                <a:solidFill>
+                  <a:srgbClr val="1A1A6E"/>
+                </a:solidFill>
+                <a:latin typeface="Times New Roman" pitchFamily="34" charset="0"/>
+                <a:ea typeface="Times New Roman" pitchFamily="34" charset="-122"/>
+                <a:cs typeface="Times New Roman" pitchFamily="34" charset="-120"/>
+              </a:rPr>
+              <a:t>: Linear, </a:t>
+            </a:r>
+            <a:pPr algn="l" indent="0" marL="0">
+              <a:lnSpc>
+                <a:spcPts val="2700"/>
+              </a:lnSpc>
+              <a:buNone/>
+            </a:pPr>
+            <a:r>
+              <a:rPr lang="en-US" sz="2100" b="1" dirty="0">
+                <a:solidFill>
+                  <a:srgbClr val="1A1A6E"/>
+                </a:solidFill>
+                <a:latin typeface="Times New Roman" pitchFamily="34" charset="0"/>
+                <a:ea typeface="Times New Roman" pitchFamily="34" charset="-122"/>
+                <a:cs typeface="Times New Roman" pitchFamily="34" charset="-120"/>
+              </a:rPr>
+              <a:t>Bias</a:t>
+            </a:r>
+            <a:pPr algn="l" indent="0" marL="0">
+              <a:lnSpc>
+                <a:spcPts val="2700"/>
+              </a:lnSpc>
+              <a:buNone/>
+            </a:pPr>
+            <a:r>
+              <a:rPr lang="en-US" sz="2100" dirty="0">
+                <a:solidFill>
+                  <a:srgbClr val="1A1A6E"/>
+                </a:solidFill>
+                <a:latin typeface="Times New Roman" pitchFamily="34" charset="0"/>
+                <a:ea typeface="Times New Roman" pitchFamily="34" charset="-122"/>
+                <a:cs typeface="Times New Roman" pitchFamily="34" charset="-120"/>
+              </a:rPr>
+              <a:t>:0</a:t>
+            </a:r>
+            <a:endParaRPr lang="en-US" sz="2100" dirty="0"/>
+          </a:p>
+        </p:txBody>
+      </p:sp>
+      <p:sp>
+        <p:nvSpPr>
+          <p:cNvPr id="85" name="Shape 52"/>
           <p:cNvSpPr/>
           <p:nvPr/>
         </p:nvSpPr>
@@ -2994,7 +3745,7 @@
       </p:sp>
       <p:sp>
         <p:nvSpPr>
-          <p:cNvPr id="64" name="Text 31"/>
+          <p:cNvPr id="86" name="Text 53"/>
           <p:cNvSpPr/>
           <p:nvPr/>
         </p:nvSpPr>

</xml_diff>